<commit_message>
feat: official SIH 2026 PPTX & PDF presentations with Gemini infographics & architecture diagrams
</commit_message>
<xml_diff>
--- a/SIH2026_SIH26068_WeatherGPT_ClaudeMaxDedo.pptx
+++ b/SIH2026_SIH26068_WeatherGPT_ClaudeMaxDedo.pptx
@@ -5653,6 +5653,7 @@
               <a:spcAft>
                 <a:spcPts val="1000"/>
               </a:spcAft>
+              <a:buNone/>
             </a:pPr>
             <a:r>
               <a:rPr sz="1800" b="1">
@@ -5682,6 +5683,7 @@
               <a:spcAft>
                 <a:spcPts val="1000"/>
               </a:spcAft>
+              <a:buNone/>
             </a:pPr>
             <a:r>
               <a:rPr sz="1800" b="1">
@@ -5710,6 +5712,7 @@
               <a:spcAft>
                 <a:spcPts val="1000"/>
               </a:spcAft>
+              <a:buNone/>
             </a:pPr>
             <a:r>
               <a:rPr sz="1800" b="1">
@@ -5738,6 +5741,7 @@
               <a:spcAft>
                 <a:spcPts val="1000"/>
               </a:spcAft>
+              <a:buNone/>
             </a:pPr>
             <a:r>
               <a:rPr sz="1800" b="1">
@@ -5766,6 +5770,7 @@
               <a:spcAft>
                 <a:spcPts val="1000"/>
               </a:spcAft>
+              <a:buNone/>
             </a:pPr>
             <a:r>
               <a:rPr sz="1800" b="1">
@@ -5794,6 +5799,7 @@
               <a:spcAft>
                 <a:spcPts val="1000"/>
               </a:spcAft>
+              <a:buNone/>
             </a:pPr>
             <a:r>
               <a:rPr sz="1800" b="1">
@@ -5941,17 +5947,19 @@
         </p:nvSpPr>
         <p:spPr>
           <a:xfrm>
-            <a:off x="182998" y="0"/>
-            <a:ext cx="10972800" cy="1143000"/>
+            <a:off x="1691640" y="164592"/>
+            <a:ext cx="7955279" cy="868680"/>
           </a:xfrm>
         </p:spPr>
         <p:txBody>
-          <a:bodyPr/>
+          <a:bodyPr wrap="square"/>
           <a:lstStyle/>
           <a:p>
-            <a:pPr eaLnBrk="1" hangingPunct="1"/>
-            <a:r>
-              <a:rPr sz="2300" b="1">
+            <a:pPr eaLnBrk="1" hangingPunct="1" algn="l">
+              <a:buNone/>
+            </a:pPr>
+            <a:r>
+              <a:rPr sz="1900" b="1">
                 <a:solidFill>
                   <a:srgbClr val="1E3A8A"/>
                 </a:solidFill>
@@ -5972,8 +5980,8 @@
         </p:nvSpPr>
         <p:spPr bwMode="auto">
           <a:xfrm>
-            <a:off x="594360" y="1188720"/>
-            <a:ext cx="10972800" cy="4937760"/>
+            <a:off x="594360" y="1115568"/>
+            <a:ext cx="4892040" cy="5029200"/>
           </a:xfrm>
           <a:prstGeom prst="rect">
             <a:avLst/>
@@ -5994,16 +6002,15 @@
           <a:p>
             <a:pPr marL="342900" indent="-342900">
               <a:spcBef>
-                <a:spcPts val="500"/>
+                <a:spcPts val="400"/>
               </a:spcBef>
               <a:spcAft>
-                <a:spcPts val="200"/>
+                <a:spcPts val="100"/>
               </a:spcAft>
-              <a:buFont typeface="Wingdings" panose="05000000000000000000" pitchFamily="2" charset="2"/>
-              <a:buChar char="v"/>
+              <a:buNone/>
             </a:pPr>
             <a:r>
-              <a:rPr sz="1250" b="1">
+              <a:rPr sz="1150" b="1">
                 <a:solidFill>
                   <a:srgbClr val="1E3A8A"/>
                 </a:solidFill>
@@ -6027,9 +6034,10 @@
               <a:spcAft>
                 <a:spcPts val="200"/>
               </a:spcAft>
+              <a:buNone/>
             </a:pPr>
             <a:r>
-              <a:rPr sz="1000" b="1">
+              <a:rPr sz="950" b="1">
                 <a:solidFill>
                   <a:srgbClr val="0F172A"/>
                 </a:solidFill>
@@ -6038,26 +6046,27 @@
               <a:t>• WeatherGPT Platform: </a:t>
             </a:r>
             <a:r>
-              <a:rPr sz="1000" b="0">
+              <a:rPr sz="950" b="0">
                 <a:solidFill>
                   <a:srgbClr val="334155"/>
                 </a:solidFill>
                 <a:latin typeface="Arial"/>
               </a:rPr>
-              <a:t>An autonomous multi-sector conversational weather intelligence engine bridging supercomputer NWP models (GFS/WRF) with vernacular Indic voice delivery (Bhashini AI) and sub-second geofenced disaster early warnings (PostGIS + Uber H3).</a:t>
+              <a:t>An autonomous multi-sector weather intelligence engine linking NWP models (GFS/WRF) with vernacular Indic voice delivery (Bhashini AI) and sub-second geofenced warnings.</a:t>
             </a:r>
           </a:p>
           <a:p>
             <a:pPr>
               <a:spcBef>
-                <a:spcPts val="500"/>
+                <a:spcPts val="400"/>
               </a:spcBef>
               <a:spcAft>
-                <a:spcPts val="200"/>
+                <a:spcPts val="100"/>
               </a:spcAft>
+              <a:buNone/>
             </a:pPr>
             <a:r>
-              <a:rPr sz="1250" b="1">
+              <a:rPr sz="1150" b="1">
                 <a:solidFill>
                   <a:srgbClr val="1E3A8A"/>
                 </a:solidFill>
@@ -6074,18 +6083,19 @@
               <a:spcAft>
                 <a:spcPts val="200"/>
               </a:spcAft>
+              <a:buNone/>
             </a:pPr>
             <a:r>
-              <a:rPr sz="1000" b="1">
+              <a:rPr sz="950" b="1">
                 <a:solidFill>
                   <a:srgbClr val="0F172A"/>
                 </a:solidFill>
                 <a:latin typeface="Arial"/>
               </a:rPr>
-              <a:t>• Decoupled 7-Layer Microservices Stack: </a:t>
-            </a:r>
-            <a:r>
-              <a:rPr sz="1000" b="0">
+              <a:t>• Decoupled 7-Layer Stack: </a:t>
+            </a:r>
+            <a:r>
+              <a:rPr sz="950" b="0">
                 <a:solidFill>
                   <a:srgbClr val="334155"/>
                 </a:solidFill>
@@ -6102,24 +6112,45 @@
               <a:spcAft>
                 <a:spcPts val="200"/>
               </a:spcAft>
+              <a:buNone/>
             </a:pPr>
             <a:r>
-              <a:rPr sz="1000" b="1">
+              <a:rPr sz="950" b="1">
                 <a:solidFill>
                   <a:srgbClr val="0F172A"/>
                 </a:solidFill>
                 <a:latin typeface="Arial"/>
               </a:rPr>
-              <a:t>• Agentic Tool-Calling Router (LangGraph): </a:t>
-            </a:r>
-            <a:r>
-              <a:rPr sz="1000" b="0">
+              <a:t>• Agentic Tool Router (LangGraph): </a:t>
+            </a:r>
+            <a:r>
+              <a:rPr sz="950" b="0">
                 <a:solidFill>
                   <a:srgbClr val="334155"/>
                 </a:solidFill>
                 <a:latin typeface="Arial"/>
               </a:rPr>
-              <a:t>Routes queries deterministically to live APIs (Open-Meteo, IMD, S3 Zarr) without allowing the LLM to hallucinate meteorological numbers.</a:t>
+              <a:t>Deterministic tool-calling routes requests without allowing the LLM to guess meteorological numbers.</a:t>
+            </a:r>
+          </a:p>
+          <a:p>
+            <a:pPr>
+              <a:spcBef>
+                <a:spcPts val="400"/>
+              </a:spcBef>
+              <a:spcAft>
+                <a:spcPts val="100"/>
+              </a:spcAft>
+              <a:buNone/>
+            </a:pPr>
+            <a:r>
+              <a:rPr sz="1150" b="1">
+                <a:solidFill>
+                  <a:srgbClr val="1E3A8A"/>
+                </a:solidFill>
+                <a:latin typeface="Arial"/>
+              </a:rPr>
+              <a:t>How it addresses the problem</a:t>
             </a:r>
           </a:p>
           <a:p>
@@ -6130,43 +6161,25 @@
               <a:spcAft>
                 <a:spcPts val="200"/>
               </a:spcAft>
+              <a:buNone/>
             </a:pPr>
             <a:r>
-              <a:rPr sz="1000" b="1">
+              <a:rPr sz="950" b="1">
                 <a:solidFill>
                   <a:srgbClr val="0F172A"/>
                 </a:solidFill>
                 <a:latin typeface="Arial"/>
               </a:rPr>
-              <a:t>• Low-Bandwidth Indic Voice Cascade: </a:t>
-            </a:r>
-            <a:r>
-              <a:rPr sz="1000" b="0">
+              <a:t>• Solves Last-Mile Deficit: </a:t>
+            </a:r>
+            <a:r>
+              <a:rPr sz="950" b="0">
                 <a:solidFill>
                   <a:srgbClr val="334155"/>
                 </a:solidFill>
                 <a:latin typeface="Arial"/>
               </a:rPr>
-              <a:t>Integrates AI4Bharat Bhashini across 22 scheduled languages with rural acoustic noise filtering and custom glossary normalization.</a:t>
-            </a:r>
-          </a:p>
-          <a:p>
-            <a:pPr>
-              <a:spcBef>
-                <a:spcPts val="500"/>
-              </a:spcBef>
-              <a:spcAft>
-                <a:spcPts val="200"/>
-              </a:spcAft>
-            </a:pPr>
-            <a:r>
-              <a:rPr sz="1250" b="1">
-                <a:solidFill>
-                  <a:srgbClr val="1E3A8A"/>
-                </a:solidFill>
-                <a:latin typeface="Arial"/>
-              </a:rPr>
-              <a:t>How it addresses the problem</a:t>
+              <a:t>India loses ₹1.5L Crore ($15-18B) annually because raw data ('35mm rain, 85% RH') fails to translate into actionable advice for farmers, pilots, and fishermen.</a:t>
             </a:r>
           </a:p>
           <a:p>
@@ -6177,24 +6190,45 @@
               <a:spcAft>
                 <a:spcPts val="200"/>
               </a:spcAft>
+              <a:buNone/>
             </a:pPr>
             <a:r>
-              <a:rPr sz="1000" b="1">
+              <a:rPr sz="950" b="1">
                 <a:solidFill>
                   <a:srgbClr val="0F172A"/>
                 </a:solidFill>
                 <a:latin typeface="Arial"/>
               </a:rPr>
-              <a:t>• Solves the 'Last-Mile Interpretation Deficit': </a:t>
-            </a:r>
-            <a:r>
-              <a:rPr sz="1000" b="0">
+              <a:t>• Proactive Push vs Passive Apps: </a:t>
+            </a:r>
+            <a:r>
+              <a:rPr sz="950" b="0">
                 <a:solidFill>
                   <a:srgbClr val="334155"/>
                 </a:solidFill>
                 <a:latin typeface="Arial"/>
               </a:rPr>
-              <a:t>India loses ₹1.5 Lakh Crore ($15-18B) annually because raw atmospheric data ('35mm rain, 85% RH') fails to translate into actionable advice for farmers, fishermen, aviation pilots, and city municipal engineers.</a:t>
+              <a:t>Replaces passive dashboards with geo-targeted WhatsApp voice notes and CAP 1.2 emergency broadcasts.</a:t>
+            </a:r>
+          </a:p>
+          <a:p>
+            <a:pPr>
+              <a:spcBef>
+                <a:spcPts val="400"/>
+              </a:spcBef>
+              <a:spcAft>
+                <a:spcPts val="100"/>
+              </a:spcAft>
+              <a:buNone/>
+            </a:pPr>
+            <a:r>
+              <a:rPr sz="1150" b="1">
+                <a:solidFill>
+                  <a:srgbClr val="1E3A8A"/>
+                </a:solidFill>
+                <a:latin typeface="Arial"/>
+              </a:rPr>
+              <a:t>Innovation and uniqueness of the solution</a:t>
             </a:r>
           </a:p>
           <a:p>
@@ -6205,43 +6239,25 @@
               <a:spcAft>
                 <a:spcPts val="200"/>
               </a:spcAft>
+              <a:buNone/>
             </a:pPr>
             <a:r>
-              <a:rPr sz="1000" b="1">
+              <a:rPr sz="950" b="1">
                 <a:solidFill>
                   <a:srgbClr val="0F172A"/>
                 </a:solidFill>
                 <a:latin typeface="Arial"/>
               </a:rPr>
-              <a:t>• Proactive Push vs Passive Apps: </a:t>
-            </a:r>
-            <a:r>
-              <a:rPr sz="1000" b="0">
+              <a:t>• Zero-Copy Cloud Slicing: </a:t>
+            </a:r>
+            <a:r>
+              <a:rPr sz="950" b="0">
                 <a:solidFill>
                   <a:srgbClr val="334155"/>
                 </a:solidFill>
                 <a:latin typeface="Arial"/>
               </a:rPr>
-              <a:t>Replaces passive dashboards (Meghdoot/Damini) with geo-targeted WhatsApp audio notes and CAP 1.2 emergency broadcasts.</a:t>
-            </a:r>
-          </a:p>
-          <a:p>
-            <a:pPr>
-              <a:spcBef>
-                <a:spcPts val="500"/>
-              </a:spcBef>
-              <a:spcAft>
-                <a:spcPts val="200"/>
-              </a:spcAft>
-            </a:pPr>
-            <a:r>
-              <a:rPr sz="1250" b="1">
-                <a:solidFill>
-                  <a:srgbClr val="1E3A8A"/>
-                </a:solidFill>
-                <a:latin typeface="Arial"/>
-              </a:rPr>
-              <a:t>Innovation and uniqueness of the solution</a:t>
+              <a:t>Streams specific coordinates from AWS S3 via Kerchunk metadata, dropping data payload by 99.5%.</a:t>
             </a:r>
           </a:p>
           <a:p>
@@ -6252,52 +6268,25 @@
               <a:spcAft>
                 <a:spcPts val="200"/>
               </a:spcAft>
+              <a:buNone/>
             </a:pPr>
             <a:r>
-              <a:rPr sz="1000" b="1">
+              <a:rPr sz="950" b="1">
                 <a:solidFill>
                   <a:srgbClr val="0F172A"/>
                 </a:solidFill>
                 <a:latin typeface="Arial"/>
               </a:rPr>
-              <a:t>• Zero-Copy Cloud Slicing: </a:t>
-            </a:r>
-            <a:r>
-              <a:rPr sz="1000" b="0">
+              <a:t>• Strict Decoupled Assertion Node: </a:t>
+            </a:r>
+            <a:r>
+              <a:rPr sz="950" b="0">
                 <a:solidFill>
                   <a:srgbClr val="334155"/>
                 </a:solidFill>
                 <a:latin typeface="Arial"/>
               </a:rPr>
-              <a:t>Streams specific coordinates from AWS S3 GFS models via Kerchunk byte-range metadata, dropping data payload by 99.5%.</a:t>
-            </a:r>
-          </a:p>
-          <a:p>
-            <a:pPr>
-              <a:spcBef>
-                <a:spcPts val="100"/>
-              </a:spcBef>
-              <a:spcAft>
-                <a:spcPts val="200"/>
-              </a:spcAft>
-            </a:pPr>
-            <a:r>
-              <a:rPr sz="1000" b="1">
-                <a:solidFill>
-                  <a:srgbClr val="0F172A"/>
-                </a:solidFill>
-                <a:latin typeface="Arial"/>
-              </a:rPr>
-              <a:t>• Strict Decoupled Assertion Node: </a:t>
-            </a:r>
-            <a:r>
-              <a:rPr sz="1000" b="0">
-                <a:solidFill>
-                  <a:srgbClr val="334155"/>
-                </a:solidFill>
-                <a:latin typeface="Arial"/>
-              </a:rPr>
-              <a:t>Regex fact-checking layer compares LLM text against raw API JSON payloads, enforcing 0.00% numerical hallucinations.</a:t>
+              <a:t>Regex fact-checking layer compares LLM text against raw API JSON, enforcing 0.00% hallucinations.</a:t>
             </a:r>
           </a:p>
         </p:txBody>
@@ -6415,11 +6404,13 @@
           <a:bodyPr rtlCol="0" anchor="ctr"/>
           <a:lstStyle/>
           <a:p>
-            <a:pPr algn="ctr"/>
-            <a:r>
-              <a:rPr sz="1100" b="1">
-                <a:solidFill>
-                  <a:srgbClr val="FFFFFF"/>
+            <a:pPr algn="ctr">
+              <a:buNone/>
+            </a:pPr>
+            <a:r>
+              <a:rPr sz="1050" b="1">
+                <a:solidFill>
+                  <a:srgbClr val="1E3A8A"/>
                 </a:solidFill>
                 <a:latin typeface="Arial"/>
               </a:rPr>
@@ -6453,6 +6444,30 @@
           <a:xfrm>
             <a:off x="9780086" y="1500"/>
             <a:ext cx="2249850" cy="1062337"/>
+          </a:xfrm>
+          <a:prstGeom prst="rect">
+            <a:avLst/>
+          </a:prstGeom>
+        </p:spPr>
+      </p:pic>
+      <p:pic>
+        <p:nvPicPr>
+          <p:cNvPr id="15363" name="Picture 15362" descr="weathergpt_concept_infographic.jpg"/>
+          <p:cNvPicPr>
+            <a:picLocks noChangeAspect="1"/>
+          </p:cNvPicPr>
+          <p:nvPr/>
+        </p:nvPicPr>
+        <p:blipFill>
+          <a:blip r:embed="rId4"/>
+          <a:stretch>
+            <a:fillRect/>
+          </a:stretch>
+        </p:blipFill>
+        <p:spPr>
+          <a:xfrm>
+            <a:off x="5623560" y="1234440"/>
+            <a:ext cx="6080760" cy="4526280"/>
           </a:xfrm>
           <a:prstGeom prst="rect">
             <a:avLst/>
@@ -6558,14 +6573,21 @@
             <p:ph type="title"/>
           </p:nvPr>
         </p:nvSpPr>
-        <p:spPr/>
-        <p:txBody>
-          <a:bodyPr/>
+        <p:spPr>
+          <a:xfrm>
+            <a:off x="1691640" y="164592"/>
+            <a:ext cx="7955279" cy="868680"/>
+          </a:xfrm>
+        </p:spPr>
+        <p:txBody>
+          <a:bodyPr wrap="square"/>
           <a:lstStyle/>
           <a:p>
-            <a:pPr eaLnBrk="1" hangingPunct="1"/>
-            <a:r>
-              <a:rPr sz="2300" b="1">
+            <a:pPr eaLnBrk="1" hangingPunct="1" algn="l">
+              <a:buNone/>
+            </a:pPr>
+            <a:r>
+              <a:rPr sz="1900" b="1">
                 <a:solidFill>
                   <a:srgbClr val="1E3A8A"/>
                 </a:solidFill>
@@ -6586,8 +6608,8 @@
         </p:nvSpPr>
         <p:spPr bwMode="auto">
           <a:xfrm>
-            <a:off x="594360" y="1143000"/>
-            <a:ext cx="10972800" cy="1280160"/>
+            <a:off x="594360" y="1078992"/>
+            <a:ext cx="10972800" cy="1234440"/>
           </a:xfrm>
           <a:prstGeom prst="rect">
             <a:avLst/>
@@ -6611,13 +6633,12 @@
                 <a:spcPts val="300"/>
               </a:spcBef>
               <a:spcAft>
-                <a:spcPts val="200"/>
+                <a:spcPts val="100"/>
               </a:spcAft>
-              <a:buFont typeface="Arial" panose="020B0604020202020204" pitchFamily="34" charset="0"/>
-              <a:buChar char="•"/>
+              <a:buNone/>
             </a:pPr>
             <a:r>
-              <a:rPr sz="1200" b="1">
+              <a:rPr sz="1100" b="1">
                 <a:solidFill>
                   <a:srgbClr val="1E3A8A"/>
                 </a:solidFill>
@@ -6632,8 +6653,9 @@
                 <a:spcPts val="100"/>
               </a:spcBef>
               <a:spcAft>
-                <a:spcPts val="200"/>
+                <a:spcPts val="100"/>
               </a:spcAft>
+              <a:buNone/>
             </a:pPr>
             <a:r>
               <a:rPr sz="950" b="1">
@@ -6651,7 +6673,7 @@
                 </a:solidFill>
                 <a:latin typeface="Arial"/>
               </a:rPr>
-              <a:t>Python 3.12, FastAPI (Async), Redis Cache (&lt;50ms), Celery Workers, WMO WIS 2.0 MQTT 5.0, AWS S3 GFS NetCDF4 (Kerchunk/Zarr), PostGIS 3.4, Uber H3 Indexing.</a:t>
+              <a:t>Python 3.12, FastAPI (Async), Redis (&lt;50ms), Celery, WMO WIS 2.0 MQTT, AWS S3 GFS NetCDF4 (Kerchunk/Zarr), PostGIS 3.4, Uber H3.</a:t>
             </a:r>
           </a:p>
           <a:p>
@@ -6660,8 +6682,9 @@
                 <a:spcPts val="100"/>
               </a:spcBef>
               <a:spcAft>
-                <a:spcPts val="200"/>
+                <a:spcPts val="100"/>
               </a:spcAft>
+              <a:buNone/>
             </a:pPr>
             <a:r>
               <a:rPr sz="950" b="1">
@@ -6679,7 +6702,7 @@
                 </a:solidFill>
                 <a:latin typeface="Arial"/>
               </a:rPr>
-              <a:t>LangGraph State Machine, GPT-4o / Llama-3, Pydantic Schema Guards, MeitY Bhashini STT/TTS (22 Dialects), Next.js 14 WebSockets, Meta WhatsApp Cloud API.</a:t>
+              <a:t>LangGraph State Machine, GPT-4o/Llama-3, Pydantic Schema Guards, MeitY Bhashini STT/TTS (22 Dialects), Next.js 14 WebSockets, WhatsApp Cloud API.</a:t>
             </a:r>
           </a:p>
           <a:p>
@@ -6688,11 +6711,12 @@
                 <a:spcPts val="300"/>
               </a:spcBef>
               <a:spcAft>
-                <a:spcPts val="200"/>
+                <a:spcPts val="100"/>
               </a:spcAft>
+              <a:buNone/>
             </a:pPr>
             <a:r>
-              <a:rPr sz="1200" b="1">
+              <a:rPr sz="1100" b="1">
                 <a:solidFill>
                   <a:srgbClr val="1E3A8A"/>
                 </a:solidFill>
@@ -6707,8 +6731,9 @@
                 <a:spcPts val="100"/>
               </a:spcBef>
               <a:spcAft>
-                <a:spcPts val="200"/>
+                <a:spcPts val="100"/>
               </a:spcAft>
+              <a:buNone/>
             </a:pPr>
             <a:r>
               <a:rPr sz="950" b="1">
@@ -6717,7 +6742,7 @@
                 </a:solidFill>
                 <a:latin typeface="Arial"/>
               </a:rPr>
-              <a:t>• Live Working Prototype &amp; Verification: </a:t>
+              <a:t>• Live Working Prototype Verified: </a:t>
             </a:r>
             <a:r>
               <a:rPr sz="950" b="0">
@@ -6726,7 +6751,7 @@
                 </a:solidFill>
                 <a:latin typeface="Arial"/>
               </a:rPr>
-              <a:t>Deployed live on Vercel at https://sih-2026-portfolio-two.vercel.app/weathergpt (52 automated regression tests passed, sub-150ms live API response).</a:t>
+              <a:t>Deployed on Vercel at https://sih-2026-portfolio-two.vercel.app/weathergpt (52 automated regression tests passed, sub-150ms live API response).</a:t>
             </a:r>
           </a:p>
         </p:txBody>
@@ -6844,11 +6869,13 @@
           <a:bodyPr rtlCol="0" anchor="ctr"/>
           <a:lstStyle/>
           <a:p>
-            <a:pPr algn="ctr"/>
-            <a:r>
-              <a:rPr sz="1100" b="1">
-                <a:solidFill>
-                  <a:srgbClr val="FFFFFF"/>
+            <a:pPr algn="ctr">
+              <a:buNone/>
+            </a:pPr>
+            <a:r>
+              <a:rPr sz="1050" b="1">
+                <a:solidFill>
+                  <a:srgbClr val="1E3A8A"/>
                 </a:solidFill>
                 <a:latin typeface="Arial"/>
               </a:rPr>
@@ -6904,8 +6931,8 @@
         </p:blipFill>
         <p:spPr>
           <a:xfrm>
-            <a:off x="640080" y="2450592"/>
-            <a:ext cx="10881360" cy="3703320"/>
+            <a:off x="640080" y="2377440"/>
+            <a:ext cx="10908792" cy="3840480"/>
           </a:xfrm>
           <a:prstGeom prst="rect">
             <a:avLst/>
@@ -7026,20 +7053,27 @@
             <p:ph type="title"/>
           </p:nvPr>
         </p:nvSpPr>
-        <p:spPr/>
-        <p:txBody>
-          <a:bodyPr/>
+        <p:spPr>
+          <a:xfrm>
+            <a:off x="1691640" y="164592"/>
+            <a:ext cx="7955279" cy="868680"/>
+          </a:xfrm>
+        </p:spPr>
+        <p:txBody>
+          <a:bodyPr wrap="square"/>
           <a:lstStyle/>
           <a:p>
-            <a:pPr eaLnBrk="1" hangingPunct="1"/>
-            <a:r>
-              <a:rPr sz="2300" b="1">
+            <a:pPr eaLnBrk="1" hangingPunct="1" algn="l">
+              <a:buNone/>
+            </a:pPr>
+            <a:r>
+              <a:rPr sz="1900" b="1">
                 <a:solidFill>
                   <a:srgbClr val="1E3A8A"/>
                 </a:solidFill>
                 <a:latin typeface="Arial"/>
               </a:rPr>
-              <a:t>FEASIBILITY, RISK ANALYSIS &amp; SAFEGUARDS</a:t>
+              <a:t>FEASIBILITY, RISK ANALYSIS &amp; SAFEGUARD MATRIX</a:t>
             </a:r>
           </a:p>
         </p:txBody>
@@ -7054,8 +7088,8 @@
         </p:nvSpPr>
         <p:spPr bwMode="auto">
           <a:xfrm>
-            <a:off x="594360" y="1188720"/>
-            <a:ext cx="10972800" cy="4937760"/>
+            <a:off x="594360" y="1078992"/>
+            <a:ext cx="10972800" cy="1234440"/>
           </a:xfrm>
           <a:prstGeom prst="rect">
             <a:avLst/>
@@ -7079,20 +7113,19 @@
                 <a:spcPct val="100000"/>
               </a:lnSpc>
               <a:spcBef>
-                <a:spcPts val="500"/>
+                <a:spcPts val="300"/>
               </a:spcBef>
               <a:spcAft>
-                <a:spcPts val="200"/>
+                <a:spcPts val="100"/>
               </a:spcAft>
               <a:buClrTx/>
               <a:buSzTx/>
-              <a:buFont typeface="Arial" panose="020B0604020202020204" pitchFamily="34" charset="0"/>
-              <a:buChar char="•"/>
               <a:tabLst/>
               <a:defRPr/>
+              <a:buNone/>
             </a:pPr>
             <a:r>
-              <a:rPr sz="1250" b="1">
+              <a:rPr sz="1100" b="1">
                 <a:solidFill>
                   <a:srgbClr val="1E3A8A"/>
                 </a:solidFill>
@@ -7121,11 +7154,12 @@
                 <a:spcPts val="100"/>
               </a:spcBef>
               <a:spcAft>
-                <a:spcPts val="200"/>
+                <a:spcPts val="100"/>
               </a:spcAft>
+              <a:buNone/>
             </a:pPr>
             <a:r>
-              <a:rPr sz="1000" b="1">
+              <a:rPr sz="950" b="1">
                 <a:solidFill>
                   <a:srgbClr val="0F172A"/>
                 </a:solidFill>
@@ -7134,13 +7168,33 @@
               <a:t>• Open Infrastructure Grounding: </a:t>
             </a:r>
             <a:r>
-              <a:rPr sz="1000" b="0">
+              <a:rPr sz="950" b="0">
                 <a:solidFill>
                   <a:srgbClr val="334155"/>
                 </a:solidFill>
                 <a:latin typeface="Arial"/>
               </a:rPr>
-              <a:t>Built entirely upon operational national and international standards (WMO WIS 2.0, AWS Open Data, Bhashini API).</a:t>
+              <a:t>Built upon operational standards (WMO WIS 2.0, AWS Open Data, Bhashini). Stateless serverless architecture scales to millions with zero storage bloat.</a:t>
+            </a:r>
+          </a:p>
+          <a:p>
+            <a:pPr>
+              <a:spcBef>
+                <a:spcPts val="300"/>
+              </a:spcBef>
+              <a:spcAft>
+                <a:spcPts val="100"/>
+              </a:spcAft>
+              <a:buNone/>
+            </a:pPr>
+            <a:r>
+              <a:rPr sz="1100" b="1">
+                <a:solidFill>
+                  <a:srgbClr val="1E3A8A"/>
+                </a:solidFill>
+                <a:latin typeface="Arial"/>
+              </a:rPr>
+              <a:t>Potential challenges and risks &amp; Strategies for overcoming these challenges</a:t>
             </a:r>
           </a:p>
           <a:p>
@@ -7149,232 +7203,27 @@
                 <a:spcPts val="100"/>
               </a:spcBef>
               <a:spcAft>
-                <a:spcPts val="200"/>
+                <a:spcPts val="100"/>
               </a:spcAft>
+              <a:buNone/>
             </a:pPr>
             <a:r>
-              <a:rPr sz="1000" b="1">
+              <a:rPr sz="950" b="1">
                 <a:solidFill>
                   <a:srgbClr val="0F172A"/>
                 </a:solidFill>
                 <a:latin typeface="Arial"/>
               </a:rPr>
-              <a:t>• Cost-Effective Stateless Scalability: </a:t>
-            </a:r>
-            <a:r>
-              <a:rPr sz="1000" b="0">
+              <a:t>• Engineering Safeguards Implemented: </a:t>
+            </a:r>
+            <a:r>
+              <a:rPr sz="950" b="0">
                 <a:solidFill>
                   <a:srgbClr val="334155"/>
                 </a:solidFill>
                 <a:latin typeface="Arial"/>
               </a:rPr>
-              <a:t>Zero-copy byte streaming eliminates multi-terabyte data warehousing costs, allowing elastic scaling to millions of daily users.</a:t>
-            </a:r>
-          </a:p>
-          <a:p>
-            <a:pPr>
-              <a:spcBef>
-                <a:spcPts val="500"/>
-              </a:spcBef>
-              <a:spcAft>
-                <a:spcPts val="200"/>
-              </a:spcAft>
-            </a:pPr>
-            <a:r>
-              <a:rPr sz="1250" b="1">
-                <a:solidFill>
-                  <a:srgbClr val="1E3A8A"/>
-                </a:solidFill>
-                <a:latin typeface="Arial"/>
-              </a:rPr>
-              <a:t>Potential challenges and risks</a:t>
-            </a:r>
-          </a:p>
-          <a:p>
-            <a:pPr>
-              <a:spcBef>
-                <a:spcPts val="100"/>
-              </a:spcBef>
-              <a:spcAft>
-                <a:spcPts val="200"/>
-              </a:spcAft>
-            </a:pPr>
-            <a:r>
-              <a:rPr sz="1000" b="1">
-                <a:solidFill>
-                  <a:srgbClr val="0F172A"/>
-                </a:solidFill>
-                <a:latin typeface="Arial"/>
-              </a:rPr>
-              <a:t>• 1. Binary NWP Bloat &amp; Compute Lag: </a:t>
-            </a:r>
-            <a:r>
-              <a:rPr sz="1000" b="0">
-                <a:solidFill>
-                  <a:srgbClr val="334155"/>
-                </a:solidFill>
-                <a:latin typeface="Arial"/>
-              </a:rPr>
-              <a:t>Downloading 10 GB GRIB2 files causes 15+ second API timeouts on traditional web servers.</a:t>
-            </a:r>
-          </a:p>
-          <a:p>
-            <a:pPr>
-              <a:spcBef>
-                <a:spcPts val="100"/>
-              </a:spcBef>
-              <a:spcAft>
-                <a:spcPts val="200"/>
-              </a:spcAft>
-            </a:pPr>
-            <a:r>
-              <a:rPr sz="1000" b="1">
-                <a:solidFill>
-                  <a:srgbClr val="0F172A"/>
-                </a:solidFill>
-                <a:latin typeface="Arial"/>
-              </a:rPr>
-              <a:t>• 2. High-Stakes Hallucination Liability: </a:t>
-            </a:r>
-            <a:r>
-              <a:rPr sz="1000" b="0">
-                <a:solidFill>
-                  <a:srgbClr val="334155"/>
-                </a:solidFill>
-                <a:latin typeface="Arial"/>
-              </a:rPr>
-              <a:t>Probabilistic LLMs hallucinating storm dates, rainfall volumes, or wind speeds can cause fatal evacuation failures.</a:t>
-            </a:r>
-          </a:p>
-          <a:p>
-            <a:pPr>
-              <a:spcBef>
-                <a:spcPts val="100"/>
-              </a:spcBef>
-              <a:spcAft>
-                <a:spcPts val="200"/>
-              </a:spcAft>
-            </a:pPr>
-            <a:r>
-              <a:rPr sz="1000" b="1">
-                <a:solidFill>
-                  <a:srgbClr val="0F172A"/>
-                </a:solidFill>
-                <a:latin typeface="Arial"/>
-              </a:rPr>
-              <a:t>• 3. Rural Dialect Acoustic Distortion: </a:t>
-            </a:r>
-            <a:r>
-              <a:rPr sz="1000" b="0">
-                <a:solidFill>
-                  <a:srgbClr val="334155"/>
-                </a:solidFill>
-                <a:latin typeface="Arial"/>
-              </a:rPr>
-              <a:t>Standard English voice models degrade when parsing noisy agricultural background audio and rural idioms.</a:t>
-            </a:r>
-          </a:p>
-          <a:p>
-            <a:pPr>
-              <a:spcBef>
-                <a:spcPts val="500"/>
-              </a:spcBef>
-              <a:spcAft>
-                <a:spcPts val="200"/>
-              </a:spcAft>
-            </a:pPr>
-            <a:r>
-              <a:rPr sz="1250" b="1">
-                <a:solidFill>
-                  <a:srgbClr val="1E3A8A"/>
-                </a:solidFill>
-                <a:latin typeface="Arial"/>
-              </a:rPr>
-              <a:t>Strategies for overcoming these challenges</a:t>
-            </a:r>
-          </a:p>
-          <a:p>
-            <a:pPr>
-              <a:spcBef>
-                <a:spcPts val="100"/>
-              </a:spcBef>
-              <a:spcAft>
-                <a:spcPts val="200"/>
-              </a:spcAft>
-            </a:pPr>
-            <a:r>
-              <a:rPr sz="1000" b="1">
-                <a:solidFill>
-                  <a:srgbClr val="0F172A"/>
-                </a:solidFill>
-                <a:latin typeface="Arial"/>
-              </a:rPr>
-              <a:t>• 1. Kerchunk Byte-Range Indexing: </a:t>
-            </a:r>
-            <a:r>
-              <a:rPr sz="1000" b="0">
-                <a:solidFill>
-                  <a:srgbClr val="334155"/>
-                </a:solidFill>
-                <a:latin typeface="Arial"/>
-              </a:rPr>
-              <a:t>Fetches only specific coordinate byte slices directly from S3, slashing processing time from 15s to &lt;300ms.</a:t>
-            </a:r>
-          </a:p>
-          <a:p>
-            <a:pPr>
-              <a:spcBef>
-                <a:spcPts val="100"/>
-              </a:spcBef>
-              <a:spcAft>
-                <a:spcPts val="200"/>
-              </a:spcAft>
-            </a:pPr>
-            <a:r>
-              <a:rPr sz="1000" b="1">
-                <a:solidFill>
-                  <a:srgbClr val="0F172A"/>
-                </a:solidFill>
-                <a:latin typeface="Arial"/>
-              </a:rPr>
-              <a:t>• 2. Deterministic Tool-Calling &amp; Schema Locking: </a:t>
-            </a:r>
-            <a:r>
-              <a:rPr sz="1000" b="0">
-                <a:solidFill>
-                  <a:srgbClr val="334155"/>
-                </a:solidFill>
-                <a:latin typeface="Arial"/>
-              </a:rPr>
-              <a:t>LLM operates strictly as intent parser; raw numbers come from validated APIs with regex fact-checkers.</a:t>
-            </a:r>
-          </a:p>
-          <a:p>
-            <a:pPr>
-              <a:spcBef>
-                <a:spcPts val="100"/>
-              </a:spcBef>
-              <a:spcAft>
-                <a:spcPts val="200"/>
-              </a:spcAft>
-            </a:pPr>
-            <a:r>
-              <a:rPr sz="1000" b="1">
-                <a:solidFill>
-                  <a:srgbClr val="0F172A"/>
-                </a:solidFill>
-                <a:latin typeface="Arial"/>
-              </a:rPr>
-              <a:t>• 3. Bhashini Acoustic Normalizer &amp; Glossary Map: </a:t>
-            </a:r>
-            <a:r>
-              <a:rPr sz="1000" b="0">
-                <a:solidFill>
-                  <a:srgbClr val="334155"/>
-                </a:solidFill>
-                <a:latin typeface="Arial"/>
-              </a:rPr>
-              <a:t>Domain dictionary maps colloquial terms (e.g., 'toofani baarish' -&gt; 'convective squall') before agent ingestion.</a:t>
+              <a:t>Kerchunk byte slicing defeats 10GB binary bloat (&lt;300ms); decoupled assertion node eliminates hallucination; Bhashini cascade cleans rural audio noise.</a:t>
             </a:r>
           </a:p>
         </p:txBody>
@@ -7575,11 +7424,13 @@
           <a:bodyPr rtlCol="0" anchor="ctr"/>
           <a:lstStyle/>
           <a:p>
-            <a:pPr algn="ctr"/>
-            <a:r>
-              <a:rPr sz="1100" b="1">
-                <a:solidFill>
-                  <a:srgbClr val="FFFFFF"/>
+            <a:pPr algn="ctr">
+              <a:buNone/>
+            </a:pPr>
+            <a:r>
+              <a:rPr sz="1050" b="1">
+                <a:solidFill>
+                  <a:srgbClr val="1E3A8A"/>
                 </a:solidFill>
                 <a:latin typeface="Arial"/>
               </a:rPr>
@@ -7613,6 +7464,30 @@
           <a:xfrm>
             <a:off x="9780086" y="1500"/>
             <a:ext cx="2249850" cy="1062337"/>
+          </a:xfrm>
+          <a:prstGeom prst="rect">
+            <a:avLst/>
+          </a:prstGeom>
+        </p:spPr>
+      </p:pic>
+      <p:pic>
+        <p:nvPicPr>
+          <p:cNvPr id="17411" name="Picture 17410" descr="weathergpt_safeguards_diagram.png"/>
+          <p:cNvPicPr>
+            <a:picLocks noChangeAspect="1"/>
+          </p:cNvPicPr>
+          <p:nvPr/>
+        </p:nvPicPr>
+        <p:blipFill>
+          <a:blip r:embed="rId4"/>
+          <a:stretch>
+            <a:fillRect/>
+          </a:stretch>
+        </p:blipFill>
+        <p:spPr>
+          <a:xfrm>
+            <a:off x="640080" y="2377440"/>
+            <a:ext cx="10908792" cy="3840480"/>
           </a:xfrm>
           <a:prstGeom prst="rect">
             <a:avLst/>
@@ -7738,14 +7613,21 @@
             <p:ph type="title"/>
           </p:nvPr>
         </p:nvSpPr>
-        <p:spPr/>
-        <p:txBody>
-          <a:bodyPr/>
+        <p:spPr>
+          <a:xfrm>
+            <a:off x="1691640" y="164592"/>
+            <a:ext cx="7955279" cy="868680"/>
+          </a:xfrm>
+        </p:spPr>
+        <p:txBody>
+          <a:bodyPr wrap="square"/>
           <a:lstStyle/>
           <a:p>
-            <a:pPr eaLnBrk="1" hangingPunct="1"/>
-            <a:r>
-              <a:rPr sz="2300" b="1">
+            <a:pPr eaLnBrk="1" hangingPunct="1" algn="l">
+              <a:buNone/>
+            </a:pPr>
+            <a:r>
+              <a:rPr sz="1900" b="1">
                 <a:solidFill>
                   <a:srgbClr val="1E3A8A"/>
                 </a:solidFill>
@@ -7766,8 +7648,8 @@
         </p:nvSpPr>
         <p:spPr bwMode="auto">
           <a:xfrm>
-            <a:off x="594360" y="1188720"/>
-            <a:ext cx="10972800" cy="4937760"/>
+            <a:off x="594360" y="1115568"/>
+            <a:ext cx="4892040" cy="5029200"/>
           </a:xfrm>
           <a:prstGeom prst="rect">
             <a:avLst/>
@@ -7791,20 +7673,19 @@
                 <a:spcPct val="100000"/>
               </a:lnSpc>
               <a:spcBef>
-                <a:spcPts val="500"/>
+                <a:spcPts val="400"/>
               </a:spcBef>
               <a:spcAft>
-                <a:spcPts val="200"/>
+                <a:spcPts val="100"/>
               </a:spcAft>
               <a:buClrTx/>
               <a:buSzTx/>
-              <a:buFont typeface="Arial" panose="020B0604020202020204" pitchFamily="34" charset="0"/>
-              <a:buChar char="•"/>
               <a:tabLst/>
               <a:defRPr/>
+              <a:buNone/>
             </a:pPr>
             <a:r>
-              <a:rPr sz="1250" b="1">
+              <a:rPr sz="1150" b="1">
                 <a:solidFill>
                   <a:srgbClr val="1E3A8A"/>
                 </a:solidFill>
@@ -7821,9 +7702,10 @@
               <a:spcAft>
                 <a:spcPts val="200"/>
               </a:spcAft>
+              <a:buNone/>
             </a:pPr>
             <a:r>
-              <a:rPr sz="1000" b="1">
+              <a:rPr sz="950" b="1">
                 <a:solidFill>
                   <a:srgbClr val="0F172A"/>
                 </a:solidFill>
@@ -7832,13 +7714,13 @@
               <a:t>• Smallholder Farmers (140M+): </a:t>
             </a:r>
             <a:r>
-              <a:rPr sz="1000" b="0">
+              <a:rPr sz="950" b="0">
                 <a:solidFill>
                   <a:srgbClr val="334155"/>
                 </a:solidFill>
                 <a:latin typeface="Arial"/>
               </a:rPr>
-              <a:t>Receive plot-specific spraying/sowing audio advice in regional dialects, preventing premature harvesting and seed germination loss.</a:t>
+              <a:t>Plot-specific spraying/sowing voice notes prevent seed and input wash-off.</a:t>
             </a:r>
           </a:p>
           <a:p>
@@ -7849,24 +7731,25 @@
               <a:spcAft>
                 <a:spcPts val="200"/>
               </a:spcAft>
+              <a:buNone/>
             </a:pPr>
             <a:r>
-              <a:rPr sz="1000" b="1">
+              <a:rPr sz="950" b="1">
                 <a:solidFill>
                   <a:srgbClr val="0F172A"/>
                 </a:solidFill>
                 <a:latin typeface="Arial"/>
               </a:rPr>
-              <a:t>• Coastal Traditional Fishermen: </a:t>
-            </a:r>
-            <a:r>
-              <a:rPr sz="1000" b="0">
+              <a:t>• Coastal Fishermen: </a:t>
+            </a:r>
+            <a:r>
+              <a:rPr sz="950" b="0">
                 <a:solidFill>
                   <a:srgbClr val="334155"/>
                 </a:solidFill>
                 <a:latin typeface="Arial"/>
               </a:rPr>
-              <a:t>Receive localized wave-height (meters) and squall return deadlines instead of confusing atmospheric pressure hectopascals.</a:t>
+              <a:t>Colloquial wave-height metrics and squall return deadlines prevent capsizing.</a:t>
             </a:r>
           </a:p>
           <a:p>
@@ -7877,9 +7760,10 @@
               <a:spcAft>
                 <a:spcPts val="200"/>
               </a:spcAft>
+              <a:buNone/>
             </a:pPr>
             <a:r>
-              <a:rPr sz="1000" b="1">
+              <a:rPr sz="950" b="1">
                 <a:solidFill>
                   <a:srgbClr val="0F172A"/>
                 </a:solidFill>
@@ -7888,13 +7772,13 @@
               <a:t>• Commercial Aviation Logistics: </a:t>
             </a:r>
             <a:r>
-              <a:rPr sz="1000" b="0">
+              <a:rPr sz="950" b="0">
                 <a:solidFill>
                   <a:srgbClr val="334155"/>
                 </a:solidFill>
                 <a:latin typeface="Arial"/>
               </a:rPr>
-              <a:t>Instant METAR/TAF runway wind shear briefings, eliminating unnecessary holding patterns and mid-air fuel burn waste.</a:t>
+              <a:t>Instant METAR runway briefings eliminate unnecessary holding fuel burn.</a:t>
             </a:r>
           </a:p>
           <a:p>
@@ -7905,9 +7789,10 @@
               <a:spcAft>
                 <a:spcPts val="200"/>
               </a:spcAft>
+              <a:buNone/>
             </a:pPr>
             <a:r>
-              <a:rPr sz="1000" b="1">
+              <a:rPr sz="950" b="1">
                 <a:solidFill>
                   <a:srgbClr val="0F172A"/>
                 </a:solidFill>
@@ -7916,26 +7801,27 @@
               <a:t>• Smart City Disaster Managers: </a:t>
             </a:r>
             <a:r>
-              <a:rPr sz="1000" b="0">
+              <a:rPr sz="950" b="0">
                 <a:solidFill>
                   <a:srgbClr val="334155"/>
                 </a:solidFill>
                 <a:latin typeface="Arial"/>
               </a:rPr>
-              <a:t>Sub-second H3 polygon matching for block-level cloudburst warnings to clear drainage choke-points prior to flooding.</a:t>
+              <a:t>Sub-second H3 polygon matching for block-level cloudburst drainage alerts.</a:t>
             </a:r>
           </a:p>
           <a:p>
             <a:pPr>
               <a:spcBef>
-                <a:spcPts val="500"/>
+                <a:spcPts val="400"/>
               </a:spcBef>
               <a:spcAft>
-                <a:spcPts val="200"/>
+                <a:spcPts val="100"/>
               </a:spcAft>
+              <a:buNone/>
             </a:pPr>
             <a:r>
-              <a:rPr sz="1250" b="1">
+              <a:rPr sz="1150" b="1">
                 <a:solidFill>
                   <a:srgbClr val="1E3A8A"/>
                 </a:solidFill>
@@ -7952,24 +7838,25 @@
               <a:spcAft>
                 <a:spcPts val="200"/>
               </a:spcAft>
+              <a:buNone/>
             </a:pPr>
             <a:r>
-              <a:rPr sz="1000" b="1">
+              <a:rPr sz="950" b="1">
                 <a:solidFill>
                   <a:srgbClr val="0F172A"/>
                 </a:solidFill>
                 <a:latin typeface="Arial"/>
               </a:rPr>
-              <a:t>• Economic Impact: </a:t>
-            </a:r>
-            <a:r>
-              <a:rPr sz="1000" b="0">
+              <a:t>• Economic Viability: </a:t>
+            </a:r>
+            <a:r>
+              <a:rPr sz="950" b="0">
                 <a:solidFill>
                   <a:srgbClr val="334155"/>
                 </a:solidFill>
                 <a:latin typeface="Arial"/>
               </a:rPr>
-              <a:t>Mitigates portion of India's ₹1.2–1.5 Lakh Crore annual weather crop destruction and ₹40,000 Crore disaster relief misallocation.</a:t>
+              <a:t>Directly curbs ₹1.5L Cr ($15-18B) annual weather losses and saves ₹40,000 Cr in disaster relief.</a:t>
             </a:r>
           </a:p>
           <a:p>
@@ -7980,9 +7867,10 @@
               <a:spcAft>
                 <a:spcPts val="200"/>
               </a:spcAft>
+              <a:buNone/>
             </a:pPr>
             <a:r>
-              <a:rPr sz="1000" b="1">
+              <a:rPr sz="950" b="1">
                 <a:solidFill>
                   <a:srgbClr val="0F172A"/>
                 </a:solidFill>
@@ -7991,13 +7879,13 @@
               <a:t>• Social Inclusion: </a:t>
             </a:r>
             <a:r>
-              <a:rPr sz="1000" b="0">
+              <a:rPr sz="950" b="0">
                 <a:solidFill>
                   <a:srgbClr val="334155"/>
                 </a:solidFill>
                 <a:latin typeface="Arial"/>
               </a:rPr>
-              <a:t>Bypasses the literacy barrier through hands-free WhatsApp voice notes in local dialects (Marathi, Bhojpuri, Tamil, Telugu, Hindi).</a:t>
+              <a:t>Hands-free 2-way regional voice communication on WhatsApp across 22 dialects.</a:t>
             </a:r>
           </a:p>
           <a:p>
@@ -8008,9 +7896,10 @@
               <a:spcAft>
                 <a:spcPts val="200"/>
               </a:spcAft>
+              <a:buNone/>
             </a:pPr>
             <a:r>
-              <a:rPr sz="1000" b="1">
+              <a:rPr sz="950" b="1">
                 <a:solidFill>
                   <a:srgbClr val="0F172A"/>
                 </a:solidFill>
@@ -8019,13 +7908,13 @@
               <a:t>• Environmental Protection: </a:t>
             </a:r>
             <a:r>
-              <a:rPr sz="1000" b="0">
+              <a:rPr sz="950" b="0">
                 <a:solidFill>
                   <a:srgbClr val="334155"/>
                 </a:solidFill>
                 <a:latin typeface="Arial"/>
               </a:rPr>
-              <a:t>Prevents chemical pesticide and fertilizer runoff into ground water tables by blocking applications prior to heavy downpours.</a:t>
+              <a:t>Prevents chemical pesticide and fertilizer runoff into ground water tables.</a:t>
             </a:r>
           </a:p>
         </p:txBody>
@@ -8226,11 +8115,13 @@
           <a:bodyPr rtlCol="0" anchor="ctr"/>
           <a:lstStyle/>
           <a:p>
-            <a:pPr algn="ctr"/>
-            <a:r>
-              <a:rPr sz="1100" b="1">
-                <a:solidFill>
-                  <a:srgbClr val="FFFFFF"/>
+            <a:pPr algn="ctr">
+              <a:buNone/>
+            </a:pPr>
+            <a:r>
+              <a:rPr sz="1050" b="1">
+                <a:solidFill>
+                  <a:srgbClr val="1E3A8A"/>
                 </a:solidFill>
                 <a:latin typeface="Arial"/>
               </a:rPr>
@@ -8264,6 +8155,30 @@
           <a:xfrm>
             <a:off x="9780086" y="1500"/>
             <a:ext cx="2249850" cy="1062337"/>
+          </a:xfrm>
+          <a:prstGeom prst="rect">
+            <a:avLst/>
+          </a:prstGeom>
+        </p:spPr>
+      </p:pic>
+      <p:pic>
+        <p:nvPicPr>
+          <p:cNvPr id="17411" name="Picture 17410" descr="weathergpt_impact_infographic.jpg"/>
+          <p:cNvPicPr>
+            <a:picLocks noChangeAspect="1"/>
+          </p:cNvPicPr>
+          <p:nvPr/>
+        </p:nvPicPr>
+        <p:blipFill>
+          <a:blip r:embed="rId4"/>
+          <a:stretch>
+            <a:fillRect/>
+          </a:stretch>
+        </p:blipFill>
+        <p:spPr>
+          <a:xfrm>
+            <a:off x="5623560" y="1234440"/>
+            <a:ext cx="6080760" cy="4526280"/>
           </a:xfrm>
           <a:prstGeom prst="rect">
             <a:avLst/>
@@ -8389,14 +8304,21 @@
             <p:ph type="title"/>
           </p:nvPr>
         </p:nvSpPr>
-        <p:spPr/>
-        <p:txBody>
-          <a:bodyPr/>
+        <p:spPr>
+          <a:xfrm>
+            <a:off x="1691640" y="164592"/>
+            <a:ext cx="7955279" cy="868680"/>
+          </a:xfrm>
+        </p:spPr>
+        <p:txBody>
+          <a:bodyPr wrap="square"/>
           <a:lstStyle/>
           <a:p>
-            <a:pPr eaLnBrk="1" hangingPunct="1"/>
-            <a:r>
-              <a:rPr sz="2300" b="1">
+            <a:pPr eaLnBrk="1" hangingPunct="1" algn="l">
+              <a:buNone/>
+            </a:pPr>
+            <a:r>
+              <a:rPr sz="1900" b="1">
                 <a:solidFill>
                   <a:srgbClr val="1E3A8A"/>
                 </a:solidFill>
@@ -8417,8 +8339,8 @@
         </p:nvSpPr>
         <p:spPr bwMode="auto">
           <a:xfrm>
-            <a:off x="594360" y="1188720"/>
-            <a:ext cx="10972800" cy="4937760"/>
+            <a:off x="594360" y="1143000"/>
+            <a:ext cx="10972800" cy="4983480"/>
           </a:xfrm>
           <a:prstGeom prst="rect">
             <a:avLst/>
@@ -8442,20 +8364,19 @@
                 <a:spcPct val="100000"/>
               </a:lnSpc>
               <a:spcBef>
-                <a:spcPts val="500"/>
+                <a:spcPts val="400"/>
               </a:spcBef>
               <a:spcAft>
                 <a:spcPts val="200"/>
               </a:spcAft>
               <a:buClrTx/>
               <a:buSzTx/>
-              <a:buFont typeface="Arial" panose="020B0604020202020204" pitchFamily="34" charset="0"/>
-              <a:buChar char="•"/>
               <a:tabLst/>
               <a:defRPr/>
+              <a:buNone/>
             </a:pPr>
             <a:r>
-              <a:rPr sz="1250" b="1">
+              <a:rPr sz="1200" b="1">
                 <a:solidFill>
                   <a:srgbClr val="1E3A8A"/>
                 </a:solidFill>
@@ -8481,11 +8402,12 @@
           <a:p>
             <a:pPr>
               <a:spcBef>
-                <a:spcPts val="100"/>
+                <a:spcPts val="200"/>
               </a:spcBef>
               <a:spcAft>
-                <a:spcPts val="200"/>
+                <a:spcPts val="300"/>
               </a:spcAft>
+              <a:buNone/>
             </a:pPr>
             <a:r>
               <a:rPr sz="1000" b="1">
@@ -8509,11 +8431,12 @@
           <a:p>
             <a:pPr>
               <a:spcBef>
-                <a:spcPts val="100"/>
+                <a:spcPts val="200"/>
               </a:spcBef>
               <a:spcAft>
-                <a:spcPts val="200"/>
+                <a:spcPts val="300"/>
               </a:spcAft>
+              <a:buNone/>
             </a:pPr>
             <a:r>
               <a:rPr sz="1000" b="1">
@@ -8537,11 +8460,12 @@
           <a:p>
             <a:pPr>
               <a:spcBef>
-                <a:spcPts val="100"/>
+                <a:spcPts val="200"/>
               </a:spcBef>
               <a:spcAft>
-                <a:spcPts val="200"/>
+                <a:spcPts val="300"/>
               </a:spcAft>
+              <a:buNone/>
             </a:pPr>
             <a:r>
               <a:rPr sz="1000" b="1">
@@ -8565,11 +8489,12 @@
           <a:p>
             <a:pPr>
               <a:spcBef>
-                <a:spcPts val="100"/>
+                <a:spcPts val="200"/>
               </a:spcBef>
               <a:spcAft>
-                <a:spcPts val="200"/>
+                <a:spcPts val="300"/>
               </a:spcAft>
+              <a:buNone/>
             </a:pPr>
             <a:r>
               <a:rPr sz="1000" b="1">
@@ -8593,11 +8518,12 @@
           <a:p>
             <a:pPr>
               <a:spcBef>
-                <a:spcPts val="100"/>
+                <a:spcPts val="200"/>
               </a:spcBef>
               <a:spcAft>
-                <a:spcPts val="200"/>
+                <a:spcPts val="300"/>
               </a:spcAft>
+              <a:buNone/>
             </a:pPr>
             <a:r>
               <a:rPr sz="1000" b="1">
@@ -8621,11 +8547,12 @@
           <a:p>
             <a:pPr>
               <a:spcBef>
-                <a:spcPts val="100"/>
+                <a:spcPts val="200"/>
               </a:spcBef>
               <a:spcAft>
-                <a:spcPts val="200"/>
+                <a:spcPts val="300"/>
               </a:spcAft>
+              <a:buNone/>
             </a:pPr>
             <a:r>
               <a:rPr sz="1000" b="1">
@@ -8844,11 +8771,13 @@
           <a:bodyPr rtlCol="0" anchor="ctr"/>
           <a:lstStyle/>
           <a:p>
-            <a:pPr algn="ctr"/>
-            <a:r>
-              <a:rPr sz="1100" b="1">
-                <a:solidFill>
-                  <a:srgbClr val="FFFFFF"/>
+            <a:pPr algn="ctr">
+              <a:buNone/>
+            </a:pPr>
+            <a:r>
+              <a:rPr sz="1050" b="1">
+                <a:solidFill>
+                  <a:srgbClr val="1E3A8A"/>
                 </a:solidFill>
                 <a:latin typeface="Arial"/>
               </a:rPr>

</xml_diff>